<commit_message>
Added new optimization matlab files
</commit_message>
<xml_diff>
--- a/Final Presentation.pptx
+++ b/Final Presentation.pptx
@@ -8,9 +8,9 @@
     <p:sldId id="256" r:id="rId2"/>
     <p:sldId id="257" r:id="rId3"/>
     <p:sldId id="258" r:id="rId4"/>
-    <p:sldId id="259" r:id="rId5"/>
-    <p:sldId id="260" r:id="rId6"/>
-    <p:sldId id="261" r:id="rId7"/>
+    <p:sldId id="261" r:id="rId5"/>
+    <p:sldId id="262" r:id="rId6"/>
+    <p:sldId id="260" r:id="rId7"/>
   </p:sldIdLst>
   <p:sldSz cx="12192000" cy="6858000"/>
   <p:notesSz cx="6858000" cy="9144000"/>
@@ -109,6 +109,11 @@
       </a:defRPr>
     </a:lvl9pPr>
   </p:defaultTextStyle>
+  <p:extLst>
+    <p:ext uri="{EFAFB233-063F-42B5-8137-9DF3F51BA10A}">
+      <p15:sldGuideLst xmlns:p15="http://schemas.microsoft.com/office/powerpoint/2012/main"/>
+    </p:ext>
+  </p:extLst>
 </p:presentation>
 </file>
 
@@ -166,6 +171,13 @@
             <a:schemeClr val="lt1"/>
           </a:fontRef>
         </p:style>
+        <p:txBody>
+          <a:bodyPr/>
+          <a:lstStyle/>
+          <a:p>
+            <a:endParaRPr lang="en-US"/>
+          </a:p>
+        </p:txBody>
       </p:sp>
       <p:sp>
         <p:nvSpPr>
@@ -204,6 +216,13 @@
             <a:schemeClr val="lt1"/>
           </a:fontRef>
         </p:style>
+        <p:txBody>
+          <a:bodyPr/>
+          <a:lstStyle/>
+          <a:p>
+            <a:endParaRPr lang="en-US"/>
+          </a:p>
+        </p:txBody>
       </p:sp>
       <p:sp>
         <p:nvSpPr>
@@ -338,7 +357,7 @@
           <a:p>
             <a:fld id="{55CEA6D2-D18B-4B02-ACEE-E6A205146A28}" type="datetimeFigureOut">
               <a:rPr lang="en-US" smtClean="0"/>
-              <a:t>4/27/2026</a:t>
+              <a:t>4/30/2026</a:t>
             </a:fld>
             <a:endParaRPr lang="en-US"/>
           </a:p>
@@ -546,7 +565,7 @@
           <a:p>
             <a:fld id="{55CEA6D2-D18B-4B02-ACEE-E6A205146A28}" type="datetimeFigureOut">
               <a:rPr lang="en-US" smtClean="0"/>
-              <a:t>4/27/2026</a:t>
+              <a:t>4/30/2026</a:t>
             </a:fld>
             <a:endParaRPr lang="en-US"/>
           </a:p>
@@ -802,7 +821,7 @@
           <a:p>
             <a:fld id="{55CEA6D2-D18B-4B02-ACEE-E6A205146A28}" type="datetimeFigureOut">
               <a:rPr lang="en-US" smtClean="0"/>
-              <a:t>4/27/2026</a:t>
+              <a:t>4/30/2026</a:t>
             </a:fld>
             <a:endParaRPr lang="en-US"/>
           </a:p>
@@ -972,7 +991,7 @@
           <a:p>
             <a:fld id="{55CEA6D2-D18B-4B02-ACEE-E6A205146A28}" type="datetimeFigureOut">
               <a:rPr lang="en-US" smtClean="0"/>
-              <a:t>4/27/2026</a:t>
+              <a:t>4/30/2026</a:t>
             </a:fld>
             <a:endParaRPr lang="en-US"/>
           </a:p>
@@ -1315,7 +1334,7 @@
           <a:p>
             <a:fld id="{55CEA6D2-D18B-4B02-ACEE-E6A205146A28}" type="datetimeFigureOut">
               <a:rPr lang="en-US" smtClean="0"/>
-              <a:t>4/27/2026</a:t>
+              <a:t>4/30/2026</a:t>
             </a:fld>
             <a:endParaRPr lang="en-US"/>
           </a:p>
@@ -1590,7 +1609,7 @@
           <a:p>
             <a:fld id="{55CEA6D2-D18B-4B02-ACEE-E6A205146A28}" type="datetimeFigureOut">
               <a:rPr lang="en-US" smtClean="0"/>
-              <a:t>4/27/2026</a:t>
+              <a:t>4/30/2026</a:t>
             </a:fld>
             <a:endParaRPr lang="en-US"/>
           </a:p>
@@ -1969,7 +1988,7 @@
           <a:p>
             <a:fld id="{55CEA6D2-D18B-4B02-ACEE-E6A205146A28}" type="datetimeFigureOut">
               <a:rPr lang="en-US" smtClean="0"/>
-              <a:t>4/27/2026</a:t>
+              <a:t>4/30/2026</a:t>
             </a:fld>
             <a:endParaRPr lang="en-US"/>
           </a:p>
@@ -2087,7 +2106,7 @@
           <a:p>
             <a:fld id="{55CEA6D2-D18B-4B02-ACEE-E6A205146A28}" type="datetimeFigureOut">
               <a:rPr lang="en-US" smtClean="0"/>
-              <a:t>4/27/2026</a:t>
+              <a:t>4/30/2026</a:t>
             </a:fld>
             <a:endParaRPr lang="en-US"/>
           </a:p>
@@ -2258,7 +2277,7 @@
           <a:p>
             <a:fld id="{55CEA6D2-D18B-4B02-ACEE-E6A205146A28}" type="datetimeFigureOut">
               <a:rPr lang="en-US" smtClean="0"/>
-              <a:t>4/27/2026</a:t>
+              <a:t>4/30/2026</a:t>
             </a:fld>
             <a:endParaRPr lang="en-US"/>
           </a:p>
@@ -2612,7 +2631,7 @@
           <a:p>
             <a:fld id="{55CEA6D2-D18B-4B02-ACEE-E6A205146A28}" type="datetimeFigureOut">
               <a:rPr lang="en-US" smtClean="0"/>
-              <a:t>4/27/2026</a:t>
+              <a:t>4/30/2026</a:t>
             </a:fld>
             <a:endParaRPr lang="en-US"/>
           </a:p>
@@ -2989,7 +3008,7 @@
           <a:p>
             <a:fld id="{55CEA6D2-D18B-4B02-ACEE-E6A205146A28}" type="datetimeFigureOut">
               <a:rPr lang="en-US" smtClean="0"/>
-              <a:t>4/27/2026</a:t>
+              <a:t>4/30/2026</a:t>
             </a:fld>
             <a:endParaRPr lang="en-US"/>
           </a:p>
@@ -3109,6 +3128,13 @@
             <a:schemeClr val="lt1"/>
           </a:fontRef>
         </p:style>
+        <p:txBody>
+          <a:bodyPr/>
+          <a:lstStyle/>
+          <a:p>
+            <a:endParaRPr lang="en-US"/>
+          </a:p>
+        </p:txBody>
       </p:sp>
       <p:sp>
         <p:nvSpPr>
@@ -3147,6 +3173,13 @@
             <a:schemeClr val="lt1"/>
           </a:fontRef>
         </p:style>
+        <p:txBody>
+          <a:bodyPr/>
+          <a:lstStyle/>
+          <a:p>
+            <a:endParaRPr lang="en-US"/>
+          </a:p>
+        </p:txBody>
       </p:sp>
       <p:sp>
         <p:nvSpPr>
@@ -3276,7 +3309,7 @@
           <a:p>
             <a:fld id="{55CEA6D2-D18B-4B02-ACEE-E6A205146A28}" type="datetimeFigureOut">
               <a:rPr lang="en-US" smtClean="0"/>
-              <a:t>4/27/2026</a:t>
+              <a:t>4/30/2026</a:t>
             </a:fld>
             <a:endParaRPr lang="en-US"/>
           </a:p>
@@ -4034,15 +4067,110 @@
             <p:ph idx="1"/>
           </p:nvPr>
         </p:nvSpPr>
-        <p:spPr/>
-        <p:txBody>
-          <a:bodyPr/>
-          <a:lstStyle/>
-          <a:p>
-            <a:endParaRPr lang="en-US"/>
-          </a:p>
-        </p:txBody>
-      </p:sp>
+        <p:spPr>
+          <a:xfrm>
+            <a:off x="1097280" y="1845734"/>
+            <a:ext cx="4951095" cy="4023360"/>
+          </a:xfrm>
+        </p:spPr>
+        <p:txBody>
+          <a:bodyPr/>
+          <a:lstStyle/>
+          <a:p>
+            <a:r>
+              <a:rPr lang="en-US" dirty="0"/>
+              <a:t>Find ground truth using …</a:t>
+            </a:r>
+          </a:p>
+          <a:p>
+            <a:r>
+              <a:rPr lang="en-US" dirty="0"/>
+              <a:t>Simulate 3 optimization methodologies: (</a:t>
+            </a:r>
+            <a:r>
+              <a:rPr lang="en-US" dirty="0" err="1"/>
+              <a:t>Baysian</a:t>
+            </a:r>
+            <a:r>
+              <a:rPr lang="en-US" dirty="0"/>
+              <a:t> Optimization (BO), Differential Evolution (DE), and (CMA-ES))</a:t>
+            </a:r>
+          </a:p>
+          <a:p>
+            <a:pPr lvl="1"/>
+            <a:r>
+              <a:rPr lang="en-US" dirty="0"/>
+              <a:t>Starting position is the parameter (Ankle angle, Knee angle, and Hip angle)</a:t>
+            </a:r>
+          </a:p>
+          <a:p>
+            <a:r>
+              <a:rPr lang="en-US" dirty="0"/>
+              <a:t>Simulate all 3 optimizations with no noise, 0.03 noise, and 0.05 noise.</a:t>
+            </a:r>
+          </a:p>
+          <a:p>
+            <a:r>
+              <a:rPr lang="en-US" dirty="0"/>
+              <a:t>Torques</a:t>
+            </a:r>
+          </a:p>
+          <a:p>
+            <a:pPr lvl="1"/>
+            <a:r>
+              <a:rPr lang="en-US" dirty="0"/>
+              <a:t>Step function, fixed at a maximum peak torque found within the literature (Citation)</a:t>
+            </a:r>
+          </a:p>
+        </p:txBody>
+      </p:sp>
+      <p:pic>
+        <p:nvPicPr>
+          <p:cNvPr id="1026" name="Picture 2">
+            <a:extLst>
+              <a:ext uri="{FF2B5EF4-FFF2-40B4-BE49-F238E27FC236}">
+                <a16:creationId xmlns:a16="http://schemas.microsoft.com/office/drawing/2014/main" id="{FE3148D4-1DAF-38D9-DDB0-07B4A3B41902}"/>
+              </a:ext>
+            </a:extLst>
+          </p:cNvPr>
+          <p:cNvPicPr>
+            <a:picLocks noChangeAspect="1" noChangeArrowheads="1"/>
+          </p:cNvPicPr>
+          <p:nvPr/>
+        </p:nvPicPr>
+        <p:blipFill>
+          <a:blip r:embed="rId2">
+            <a:extLst>
+              <a:ext uri="{28A0092B-C50C-407E-A947-70E740481C1C}">
+                <a14:useLocalDpi xmlns:a14="http://schemas.microsoft.com/office/drawing/2010/main" val="0"/>
+              </a:ext>
+            </a:extLst>
+          </a:blip>
+          <a:srcRect/>
+          <a:stretch>
+            <a:fillRect/>
+          </a:stretch>
+        </p:blipFill>
+        <p:spPr bwMode="auto">
+          <a:xfrm>
+            <a:off x="6048375" y="1845734"/>
+            <a:ext cx="6143625" cy="1657350"/>
+          </a:xfrm>
+          <a:prstGeom prst="rect">
+            <a:avLst/>
+          </a:prstGeom>
+          <a:noFill/>
+          <a:extLst>
+            <a:ext uri="{909E8E84-426E-40DD-AFC4-6F175D3DCCD1}">
+              <a14:hiddenFill xmlns:a14="http://schemas.microsoft.com/office/drawing/2010/main">
+                <a:solidFill>
+                  <a:srgbClr val="FFFFFF"/>
+                </a:solidFill>
+              </a14:hiddenFill>
+            </a:ext>
+          </a:extLst>
+        </p:spPr>
+      </p:pic>
     </p:spTree>
     <p:extLst>
       <p:ext uri="{BB962C8B-B14F-4D97-AF65-F5344CB8AC3E}">
@@ -4061,7 +4189,13 @@
   <p:cSld>
     <p:spTree>
       <p:nvGrpSpPr>
-        <p:cNvPr id="1" name=""/>
+        <p:cNvPr id="1" name="">
+          <a:extLst>
+            <a:ext uri="{FF2B5EF4-FFF2-40B4-BE49-F238E27FC236}">
+              <a16:creationId xmlns:a16="http://schemas.microsoft.com/office/drawing/2014/main" id="{72EFF013-62F2-3AE8-A591-BBCE889BE901}"/>
+            </a:ext>
+          </a:extLst>
+        </p:cNvPr>
         <p:cNvGrpSpPr/>
         <p:nvPr/>
       </p:nvGrpSpPr>
@@ -4078,7 +4212,7 @@
           <p:cNvPr id="2" name="Title 1">
             <a:extLst>
               <a:ext uri="{FF2B5EF4-FFF2-40B4-BE49-F238E27FC236}">
-                <a16:creationId xmlns:a16="http://schemas.microsoft.com/office/drawing/2014/main" id="{D3AB356C-DC98-584A-B8E8-DA88A6CDF3AF}"/>
+                <a16:creationId xmlns:a16="http://schemas.microsoft.com/office/drawing/2014/main" id="{B29CAF73-77BE-49EF-D40A-1DD3DF93CEDF}"/>
               </a:ext>
             </a:extLst>
           </p:cNvPr>
@@ -4096,7 +4230,7 @@
           <a:p>
             <a:r>
               <a:rPr lang="en-US" dirty="0"/>
-              <a:t>Results</a:t>
+              <a:t>Optimizations at different noise levels</a:t>
             </a:r>
           </a:p>
         </p:txBody>
@@ -4106,7 +4240,7 @@
           <p:cNvPr id="3" name="Content Placeholder 2">
             <a:extLst>
               <a:ext uri="{FF2B5EF4-FFF2-40B4-BE49-F238E27FC236}">
-                <a16:creationId xmlns:a16="http://schemas.microsoft.com/office/drawing/2014/main" id="{694446F1-575A-785A-75E7-6DA102AAC27A}"/>
+                <a16:creationId xmlns:a16="http://schemas.microsoft.com/office/drawing/2014/main" id="{BD2F4FB9-FDF0-1E43-3E78-67B44956605A}"/>
               </a:ext>
             </a:extLst>
           </p:cNvPr>
@@ -4117,19 +4251,135 @@
             <p:ph idx="1"/>
           </p:nvPr>
         </p:nvSpPr>
-        <p:spPr/>
-        <p:txBody>
-          <a:bodyPr/>
-          <a:lstStyle/>
-          <a:p>
-            <a:endParaRPr lang="en-US"/>
-          </a:p>
-        </p:txBody>
-      </p:sp>
+        <p:spPr>
+          <a:xfrm>
+            <a:off x="1097280" y="4819650"/>
+            <a:ext cx="10058400" cy="1049444"/>
+          </a:xfrm>
+        </p:spPr>
+        <p:txBody>
+          <a:bodyPr/>
+          <a:lstStyle/>
+          <a:p>
+            <a:r>
+              <a:rPr lang="en-US" dirty="0"/>
+              <a:t>Placeholder text</a:t>
+            </a:r>
+          </a:p>
+        </p:txBody>
+      </p:sp>
+      <p:pic>
+        <p:nvPicPr>
+          <p:cNvPr id="4" name="Content Placeholder 12">
+            <a:extLst>
+              <a:ext uri="{FF2B5EF4-FFF2-40B4-BE49-F238E27FC236}">
+                <a16:creationId xmlns:a16="http://schemas.microsoft.com/office/drawing/2014/main" id="{AE975B5E-22B1-F2CB-D3A7-7B49FC31ABB8}"/>
+              </a:ext>
+            </a:extLst>
+          </p:cNvPr>
+          <p:cNvPicPr>
+            <a:picLocks noChangeAspect="1"/>
+          </p:cNvPicPr>
+          <p:nvPr/>
+        </p:nvPicPr>
+        <p:blipFill>
+          <a:blip r:embed="rId2">
+            <a:extLst>
+              <a:ext uri="{28A0092B-C50C-407E-A947-70E740481C1C}">
+                <a14:useLocalDpi xmlns:a14="http://schemas.microsoft.com/office/drawing/2010/main" val="0"/>
+              </a:ext>
+            </a:extLst>
+          </a:blip>
+          <a:stretch>
+            <a:fillRect/>
+          </a:stretch>
+        </p:blipFill>
+        <p:spPr>
+          <a:xfrm>
+            <a:off x="92898" y="1940308"/>
+            <a:ext cx="4002068" cy="2650058"/>
+          </a:xfrm>
+          <a:prstGeom prst="rect">
+            <a:avLst/>
+          </a:prstGeom>
+        </p:spPr>
+      </p:pic>
+      <p:pic>
+        <p:nvPicPr>
+          <p:cNvPr id="5" name="Picture 4">
+            <a:extLst>
+              <a:ext uri="{FF2B5EF4-FFF2-40B4-BE49-F238E27FC236}">
+                <a16:creationId xmlns:a16="http://schemas.microsoft.com/office/drawing/2014/main" id="{A59499CE-BBA0-606A-1618-B4944F1FDB23}"/>
+              </a:ext>
+            </a:extLst>
+          </p:cNvPr>
+          <p:cNvPicPr>
+            <a:picLocks noChangeAspect="1"/>
+          </p:cNvPicPr>
+          <p:nvPr/>
+        </p:nvPicPr>
+        <p:blipFill>
+          <a:blip r:embed="rId3">
+            <a:extLst>
+              <a:ext uri="{28A0092B-C50C-407E-A947-70E740481C1C}">
+                <a14:useLocalDpi xmlns:a14="http://schemas.microsoft.com/office/drawing/2010/main" val="0"/>
+              </a:ext>
+            </a:extLst>
+          </a:blip>
+          <a:stretch>
+            <a:fillRect/>
+          </a:stretch>
+        </p:blipFill>
+        <p:spPr>
+          <a:xfrm>
+            <a:off x="8097031" y="1940305"/>
+            <a:ext cx="4002071" cy="2650061"/>
+          </a:xfrm>
+          <a:prstGeom prst="rect">
+            <a:avLst/>
+          </a:prstGeom>
+        </p:spPr>
+      </p:pic>
+      <p:pic>
+        <p:nvPicPr>
+          <p:cNvPr id="6" name="Picture 5">
+            <a:extLst>
+              <a:ext uri="{FF2B5EF4-FFF2-40B4-BE49-F238E27FC236}">
+                <a16:creationId xmlns:a16="http://schemas.microsoft.com/office/drawing/2014/main" id="{1FC6AE21-34EC-454E-D562-1797B4C687A6}"/>
+              </a:ext>
+            </a:extLst>
+          </p:cNvPr>
+          <p:cNvPicPr>
+            <a:picLocks noChangeAspect="1"/>
+          </p:cNvPicPr>
+          <p:nvPr/>
+        </p:nvPicPr>
+        <p:blipFill>
+          <a:blip r:embed="rId4">
+            <a:extLst>
+              <a:ext uri="{28A0092B-C50C-407E-A947-70E740481C1C}">
+                <a14:useLocalDpi xmlns:a14="http://schemas.microsoft.com/office/drawing/2010/main" val="0"/>
+              </a:ext>
+            </a:extLst>
+          </a:blip>
+          <a:stretch>
+            <a:fillRect/>
+          </a:stretch>
+        </p:blipFill>
+        <p:spPr>
+          <a:xfrm>
+            <a:off x="4094966" y="1940308"/>
+            <a:ext cx="4002068" cy="2650058"/>
+          </a:xfrm>
+          <a:prstGeom prst="rect">
+            <a:avLst/>
+          </a:prstGeom>
+        </p:spPr>
+      </p:pic>
     </p:spTree>
     <p:extLst>
       <p:ext uri="{BB962C8B-B14F-4D97-AF65-F5344CB8AC3E}">
-        <p14:creationId xmlns:p14="http://schemas.microsoft.com/office/powerpoint/2010/main" val="1719772044"/>
+        <p14:creationId xmlns:p14="http://schemas.microsoft.com/office/powerpoint/2010/main" val="1034178268"/>
       </p:ext>
     </p:extLst>
   </p:cSld>
@@ -4161,7 +4411,7 @@
           <p:cNvPr id="2" name="Title 1">
             <a:extLst>
               <a:ext uri="{FF2B5EF4-FFF2-40B4-BE49-F238E27FC236}">
-                <a16:creationId xmlns:a16="http://schemas.microsoft.com/office/drawing/2014/main" id="{8D711B02-6FDD-0FCB-2A7A-6D8A0AD49D92}"/>
+                <a16:creationId xmlns:a16="http://schemas.microsoft.com/office/drawing/2014/main" id="{66D0D752-3846-CAA1-F382-78F7B78D6184}"/>
               </a:ext>
             </a:extLst>
           </p:cNvPr>
@@ -4179,7 +4429,7 @@
           <a:p>
             <a:r>
               <a:rPr lang="en-US" dirty="0"/>
-              <a:t>Key Takeaways</a:t>
+              <a:t>Comparison of optimized jump height</a:t>
             </a:r>
           </a:p>
         </p:txBody>
@@ -4189,7 +4439,7 @@
           <p:cNvPr id="3" name="Content Placeholder 2">
             <a:extLst>
               <a:ext uri="{FF2B5EF4-FFF2-40B4-BE49-F238E27FC236}">
-                <a16:creationId xmlns:a16="http://schemas.microsoft.com/office/drawing/2014/main" id="{D1571012-E894-2C8F-988F-458AE2C04221}"/>
+                <a16:creationId xmlns:a16="http://schemas.microsoft.com/office/drawing/2014/main" id="{658DE0E4-6F14-475E-AAE5-7C71DD53BC01}"/>
               </a:ext>
             </a:extLst>
           </p:cNvPr>
@@ -4205,14 +4455,53 @@
           <a:bodyPr/>
           <a:lstStyle/>
           <a:p>
-            <a:endParaRPr lang="en-US"/>
-          </a:p>
-        </p:txBody>
-      </p:sp>
+            <a:r>
+              <a:rPr lang="en-US" dirty="0"/>
+              <a:t>Placeholder</a:t>
+            </a:r>
+          </a:p>
+        </p:txBody>
+      </p:sp>
+      <p:pic>
+        <p:nvPicPr>
+          <p:cNvPr id="5" name="Picture 4">
+            <a:extLst>
+              <a:ext uri="{FF2B5EF4-FFF2-40B4-BE49-F238E27FC236}">
+                <a16:creationId xmlns:a16="http://schemas.microsoft.com/office/drawing/2014/main" id="{C67C6460-94DF-10B1-B57D-A5F0E4E5E3BC}"/>
+              </a:ext>
+            </a:extLst>
+          </p:cNvPr>
+          <p:cNvPicPr>
+            <a:picLocks noChangeAspect="1"/>
+          </p:cNvPicPr>
+          <p:nvPr/>
+        </p:nvPicPr>
+        <p:blipFill>
+          <a:blip r:embed="rId2">
+            <a:extLst>
+              <a:ext uri="{28A0092B-C50C-407E-A947-70E740481C1C}">
+                <a14:useLocalDpi xmlns:a14="http://schemas.microsoft.com/office/drawing/2010/main" val="0"/>
+              </a:ext>
+            </a:extLst>
+          </a:blip>
+          <a:stretch>
+            <a:fillRect/>
+          </a:stretch>
+        </p:blipFill>
+        <p:spPr>
+          <a:xfrm>
+            <a:off x="2600325" y="1921934"/>
+            <a:ext cx="5608783" cy="4211325"/>
+          </a:xfrm>
+          <a:prstGeom prst="rect">
+            <a:avLst/>
+          </a:prstGeom>
+        </p:spPr>
+      </p:pic>
     </p:spTree>
     <p:extLst>
       <p:ext uri="{BB962C8B-B14F-4D97-AF65-F5344CB8AC3E}">
-        <p14:creationId xmlns:p14="http://schemas.microsoft.com/office/powerpoint/2010/main" val="477067032"/>
+        <p14:creationId xmlns:p14="http://schemas.microsoft.com/office/powerpoint/2010/main" val="2950583112"/>
       </p:ext>
     </p:extLst>
   </p:cSld>
@@ -4244,7 +4533,7 @@
           <p:cNvPr id="2" name="Title 1">
             <a:extLst>
               <a:ext uri="{FF2B5EF4-FFF2-40B4-BE49-F238E27FC236}">
-                <a16:creationId xmlns:a16="http://schemas.microsoft.com/office/drawing/2014/main" id="{8841D041-E099-3D5A-07E6-BBA87054FC07}"/>
+                <a16:creationId xmlns:a16="http://schemas.microsoft.com/office/drawing/2014/main" id="{8D711B02-6FDD-0FCB-2A7A-6D8A0AD49D92}"/>
               </a:ext>
             </a:extLst>
           </p:cNvPr>
@@ -4262,7 +4551,7 @@
           <a:p>
             <a:r>
               <a:rPr lang="en-US" dirty="0"/>
-              <a:t>References</a:t>
+              <a:t>Key Takeaways</a:t>
             </a:r>
           </a:p>
         </p:txBody>
@@ -4272,7 +4561,7 @@
           <p:cNvPr id="3" name="Content Placeholder 2">
             <a:extLst>
               <a:ext uri="{FF2B5EF4-FFF2-40B4-BE49-F238E27FC236}">
-                <a16:creationId xmlns:a16="http://schemas.microsoft.com/office/drawing/2014/main" id="{319259CE-11C8-1305-67EA-91EA517A9BD8}"/>
+                <a16:creationId xmlns:a16="http://schemas.microsoft.com/office/drawing/2014/main" id="{D1571012-E894-2C8F-988F-458AE2C04221}"/>
               </a:ext>
             </a:extLst>
           </p:cNvPr>
@@ -4295,7 +4584,7 @@
     </p:spTree>
     <p:extLst>
       <p:ext uri="{BB962C8B-B14F-4D97-AF65-F5344CB8AC3E}">
-        <p14:creationId xmlns:p14="http://schemas.microsoft.com/office/powerpoint/2010/main" val="3430819927"/>
+        <p14:creationId xmlns:p14="http://schemas.microsoft.com/office/powerpoint/2010/main" val="477067032"/>
       </p:ext>
     </p:extLst>
   </p:cSld>

</xml_diff>